<commit_message>
Algunos ajustes para puntualizar detalles
</commit_message>
<xml_diff>
--- a/Gestion-Empresa-Proyectos/esquema_basico_del_funcionamiento_economico_de_una_empresa.pptx
+++ b/Gestion-Empresa-Proyectos/esquema_basico_del_funcionamiento_economico_de_una_empresa.pptx
@@ -245,7 +245,7 @@
           <a:p>
             <a:fld id="{2F8335AE-28F8-4460-B9C7-85D77893EB64}" type="datetimeFigureOut">
               <a:rPr lang="es-ES_tradnl" smtClean="0"/>
-              <a:t>31/05/2024</a:t>
+              <a:t>16/07/2026</a:t>
             </a:fld>
             <a:endParaRPr lang="es-ES_tradnl"/>
           </a:p>
@@ -415,7 +415,7 @@
           <a:p>
             <a:fld id="{2F8335AE-28F8-4460-B9C7-85D77893EB64}" type="datetimeFigureOut">
               <a:rPr lang="es-ES_tradnl" smtClean="0"/>
-              <a:t>31/05/2024</a:t>
+              <a:t>16/07/2026</a:t>
             </a:fld>
             <a:endParaRPr lang="es-ES_tradnl"/>
           </a:p>
@@ -595,7 +595,7 @@
           <a:p>
             <a:fld id="{2F8335AE-28F8-4460-B9C7-85D77893EB64}" type="datetimeFigureOut">
               <a:rPr lang="es-ES_tradnl" smtClean="0"/>
-              <a:t>31/05/2024</a:t>
+              <a:t>16/07/2026</a:t>
             </a:fld>
             <a:endParaRPr lang="es-ES_tradnl"/>
           </a:p>
@@ -765,7 +765,7 @@
           <a:p>
             <a:fld id="{2F8335AE-28F8-4460-B9C7-85D77893EB64}" type="datetimeFigureOut">
               <a:rPr lang="es-ES_tradnl" smtClean="0"/>
-              <a:t>31/05/2024</a:t>
+              <a:t>16/07/2026</a:t>
             </a:fld>
             <a:endParaRPr lang="es-ES_tradnl"/>
           </a:p>
@@ -1011,7 +1011,7 @@
           <a:p>
             <a:fld id="{2F8335AE-28F8-4460-B9C7-85D77893EB64}" type="datetimeFigureOut">
               <a:rPr lang="es-ES_tradnl" smtClean="0"/>
-              <a:t>31/05/2024</a:t>
+              <a:t>16/07/2026</a:t>
             </a:fld>
             <a:endParaRPr lang="es-ES_tradnl"/>
           </a:p>
@@ -1243,7 +1243,7 @@
           <a:p>
             <a:fld id="{2F8335AE-28F8-4460-B9C7-85D77893EB64}" type="datetimeFigureOut">
               <a:rPr lang="es-ES_tradnl" smtClean="0"/>
-              <a:t>31/05/2024</a:t>
+              <a:t>16/07/2026</a:t>
             </a:fld>
             <a:endParaRPr lang="es-ES_tradnl"/>
           </a:p>
@@ -1610,7 +1610,7 @@
           <a:p>
             <a:fld id="{2F8335AE-28F8-4460-B9C7-85D77893EB64}" type="datetimeFigureOut">
               <a:rPr lang="es-ES_tradnl" smtClean="0"/>
-              <a:t>31/05/2024</a:t>
+              <a:t>16/07/2026</a:t>
             </a:fld>
             <a:endParaRPr lang="es-ES_tradnl"/>
           </a:p>
@@ -1728,7 +1728,7 @@
           <a:p>
             <a:fld id="{2F8335AE-28F8-4460-B9C7-85D77893EB64}" type="datetimeFigureOut">
               <a:rPr lang="es-ES_tradnl" smtClean="0"/>
-              <a:t>31/05/2024</a:t>
+              <a:t>16/07/2026</a:t>
             </a:fld>
             <a:endParaRPr lang="es-ES_tradnl"/>
           </a:p>
@@ -1823,7 +1823,7 @@
           <a:p>
             <a:fld id="{2F8335AE-28F8-4460-B9C7-85D77893EB64}" type="datetimeFigureOut">
               <a:rPr lang="es-ES_tradnl" smtClean="0"/>
-              <a:t>31/05/2024</a:t>
+              <a:t>16/07/2026</a:t>
             </a:fld>
             <a:endParaRPr lang="es-ES_tradnl"/>
           </a:p>
@@ -2100,7 +2100,7 @@
           <a:p>
             <a:fld id="{2F8335AE-28F8-4460-B9C7-85D77893EB64}" type="datetimeFigureOut">
               <a:rPr lang="es-ES_tradnl" smtClean="0"/>
-              <a:t>31/05/2024</a:t>
+              <a:t>16/07/2026</a:t>
             </a:fld>
             <a:endParaRPr lang="es-ES_tradnl"/>
           </a:p>
@@ -2353,7 +2353,7 @@
           <a:p>
             <a:fld id="{2F8335AE-28F8-4460-B9C7-85D77893EB64}" type="datetimeFigureOut">
               <a:rPr lang="es-ES_tradnl" smtClean="0"/>
-              <a:t>31/05/2024</a:t>
+              <a:t>16/07/2026</a:t>
             </a:fld>
             <a:endParaRPr lang="es-ES_tradnl"/>
           </a:p>
@@ -2566,7 +2566,7 @@
           <a:p>
             <a:fld id="{2F8335AE-28F8-4460-B9C7-85D77893EB64}" type="datetimeFigureOut">
               <a:rPr lang="es-ES_tradnl" smtClean="0"/>
-              <a:t>31/05/2024</a:t>
+              <a:t>16/07/2026</a:t>
             </a:fld>
             <a:endParaRPr lang="es-ES_tradnl"/>
           </a:p>
@@ -3533,230 +3533,88 @@
           </p:cxnSp>
         </p:grpSp>
       </p:grpSp>
-      <p:grpSp>
-        <p:nvGrpSpPr>
-          <p:cNvPr id="107" name="Grupo 106"/>
-          <p:cNvGrpSpPr/>
+      <p:pic>
+        <p:nvPicPr>
+          <p:cNvPr id="69" name="Imagen 68"/>
+          <p:cNvPicPr>
+            <a:picLocks noChangeAspect="1"/>
+          </p:cNvPicPr>
           <p:nvPr/>
-        </p:nvGrpSpPr>
-        <p:grpSpPr>
+        </p:nvPicPr>
+        <p:blipFill>
+          <a:blip r:embed="rId4">
+            <a:extLst>
+              <a:ext uri="{28A0092B-C50C-407E-A947-70E740481C1C}">
+                <a14:useLocalDpi xmlns:a14="http://schemas.microsoft.com/office/drawing/2010/main" val="0"/>
+              </a:ext>
+            </a:extLst>
+          </a:blip>
+          <a:stretch>
+            <a:fillRect/>
+          </a:stretch>
+        </p:blipFill>
+        <p:spPr>
           <a:xfrm>
-            <a:off x="577794" y="2234033"/>
-            <a:ext cx="1959785" cy="1350901"/>
-            <a:chOff x="1074784" y="2248165"/>
-            <a:chExt cx="1959785" cy="1350901"/>
-          </a:xfrm>
-        </p:grpSpPr>
-        <p:pic>
-          <p:nvPicPr>
-            <p:cNvPr id="69" name="Imagen 68"/>
-            <p:cNvPicPr>
-              <a:picLocks noChangeAspect="1"/>
-            </p:cNvPicPr>
-            <p:nvPr/>
-          </p:nvPicPr>
-          <p:blipFill>
-            <a:blip r:embed="rId4">
-              <a:extLst>
-                <a:ext uri="{28A0092B-C50C-407E-A947-70E740481C1C}">
-                  <a14:useLocalDpi xmlns:a14="http://schemas.microsoft.com/office/drawing/2010/main" val="0"/>
-                </a:ext>
-              </a:extLst>
-            </a:blip>
-            <a:stretch>
-              <a:fillRect/>
-            </a:stretch>
-          </p:blipFill>
-          <p:spPr>
-            <a:xfrm>
-              <a:off x="2128929" y="2902741"/>
-              <a:ext cx="524301" cy="670618"/>
-            </a:xfrm>
-            <a:prstGeom prst="rect">
-              <a:avLst/>
-            </a:prstGeom>
-          </p:spPr>
-        </p:pic>
-        <p:sp>
-          <p:nvSpPr>
-            <p:cNvPr id="75" name="CuadroTexto 74"/>
-            <p:cNvSpPr txBox="1"/>
-            <p:nvPr/>
-          </p:nvSpPr>
-          <p:spPr>
-            <a:xfrm>
-              <a:off x="1074784" y="2952735"/>
-              <a:ext cx="1225174" cy="646331"/>
-            </a:xfrm>
-            <a:prstGeom prst="rect">
-              <a:avLst/>
-            </a:prstGeom>
-            <a:noFill/>
-          </p:spPr>
-          <p:txBody>
-            <a:bodyPr wrap="square" rtlCol="0">
-              <a:spAutoFit/>
-            </a:bodyPr>
-            <a:lstStyle/>
-            <a:p>
-              <a:pPr algn="ctr"/>
-              <a:r>
-                <a:rPr lang="en-US" dirty="0" err="1" smtClean="0"/>
-                <a:t>capitales</a:t>
-              </a:r>
-              <a:r>
-                <a:rPr lang="en-US" dirty="0" smtClean="0"/>
-                <a:t/>
-              </a:r>
-              <a:br>
-                <a:rPr lang="en-US" dirty="0" smtClean="0"/>
-              </a:br>
-              <a:r>
-                <a:rPr lang="en-US" dirty="0" err="1" smtClean="0"/>
-                <a:t>externos</a:t>
-              </a:r>
-              <a:endParaRPr lang="es-ES_tradnl" dirty="0"/>
-            </a:p>
-          </p:txBody>
-        </p:sp>
-        <p:sp>
-          <p:nvSpPr>
-            <p:cNvPr id="102" name="Nube 101"/>
-            <p:cNvSpPr/>
-            <p:nvPr/>
-          </p:nvSpPr>
-          <p:spPr>
-            <a:xfrm>
-              <a:off x="1499536" y="2248165"/>
-              <a:ext cx="1535033" cy="400900"/>
-            </a:xfrm>
-            <a:prstGeom prst="cloud">
-              <a:avLst/>
-            </a:prstGeom>
-          </p:spPr>
-          <p:style>
-            <a:lnRef idx="2">
-              <a:schemeClr val="accent1">
-                <a:shade val="50000"/>
-              </a:schemeClr>
-            </a:lnRef>
-            <a:fillRef idx="1">
-              <a:schemeClr val="accent1"/>
-            </a:fillRef>
-            <a:effectRef idx="0">
-              <a:schemeClr val="accent1"/>
-            </a:effectRef>
-            <a:fontRef idx="minor">
-              <a:schemeClr val="lt1"/>
-            </a:fontRef>
-          </p:style>
-          <p:txBody>
-            <a:bodyPr rtlCol="0" anchor="ctr"/>
-            <a:lstStyle/>
-            <a:p>
-              <a:pPr algn="ctr"/>
-              <a:r>
-                <a:rPr lang="en-US" sz="1200" dirty="0" err="1" smtClean="0"/>
-                <a:t>Inversores</a:t>
-              </a:r>
-              <a:r>
-                <a:rPr lang="en-US" sz="1200" dirty="0" smtClean="0"/>
-                <a:t> y </a:t>
-              </a:r>
-              <a:r>
-                <a:rPr lang="en-US" sz="1200" dirty="0" err="1" smtClean="0"/>
-                <a:t>prestamistas</a:t>
-              </a:r>
-              <a:endParaRPr lang="es-ES_tradnl" sz="1200" dirty="0"/>
-            </a:p>
-          </p:txBody>
-        </p:sp>
-      </p:grpSp>
-      <p:grpSp>
-        <p:nvGrpSpPr>
-          <p:cNvPr id="105" name="Grupo 104"/>
-          <p:cNvGrpSpPr/>
+            <a:off x="1631939" y="2888609"/>
+            <a:ext cx="524301" cy="670618"/>
+          </a:xfrm>
+          <a:prstGeom prst="rect">
+            <a:avLst/>
+          </a:prstGeom>
+        </p:spPr>
+      </p:pic>
+      <p:sp>
+        <p:nvSpPr>
+          <p:cNvPr id="75" name="CuadroTexto 74"/>
+          <p:cNvSpPr txBox="1"/>
           <p:nvPr/>
-        </p:nvGrpSpPr>
-        <p:grpSpPr>
+        </p:nvSpPr>
+        <p:spPr>
           <a:xfrm>
-            <a:off x="8896785" y="5100088"/>
-            <a:ext cx="1482863" cy="1348652"/>
-            <a:chOff x="8001768" y="4459579"/>
-            <a:chExt cx="1482863" cy="1348652"/>
-          </a:xfrm>
-        </p:grpSpPr>
-        <p:pic>
-          <p:nvPicPr>
-            <p:cNvPr id="5" name="Imagen 4" descr="Free photo: Water Pump, Industrial, Industry - Free Image ..."/>
-            <p:cNvPicPr>
-              <a:picLocks noChangeAspect="1"/>
-            </p:cNvPicPr>
-            <p:nvPr/>
-          </p:nvPicPr>
-          <p:blipFill>
-            <a:blip r:embed="rId3">
-              <a:extLst>
-                <a:ext uri="{28A0092B-C50C-407E-A947-70E740481C1C}">
-                  <a14:useLocalDpi xmlns:a14="http://schemas.microsoft.com/office/drawing/2010/main" val="0"/>
-                </a:ext>
-              </a:extLst>
-            </a:blip>
-            <a:stretch>
-              <a:fillRect/>
-            </a:stretch>
-          </p:blipFill>
-          <p:spPr>
-            <a:xfrm>
-              <a:off x="8001768" y="4459579"/>
-              <a:ext cx="1482863" cy="988575"/>
-            </a:xfrm>
-            <a:prstGeom prst="rect">
-              <a:avLst/>
-            </a:prstGeom>
-          </p:spPr>
-        </p:pic>
-        <p:sp>
-          <p:nvSpPr>
-            <p:cNvPr id="104" name="CuadroTexto 103"/>
-            <p:cNvSpPr txBox="1"/>
-            <p:nvPr/>
-          </p:nvSpPr>
-          <p:spPr>
-            <a:xfrm>
-              <a:off x="8307024" y="5438899"/>
-              <a:ext cx="796244" cy="369332"/>
-            </a:xfrm>
-            <a:prstGeom prst="rect">
-              <a:avLst/>
-            </a:prstGeom>
-            <a:noFill/>
-          </p:spPr>
-          <p:txBody>
-            <a:bodyPr wrap="none" rtlCol="0">
-              <a:spAutoFit/>
-            </a:bodyPr>
-            <a:lstStyle/>
-            <a:p>
-              <a:r>
-                <a:rPr lang="en-US" dirty="0" err="1" smtClean="0"/>
-                <a:t>ventas</a:t>
-              </a:r>
-              <a:endParaRPr lang="es-ES_tradnl" dirty="0"/>
-            </a:p>
-          </p:txBody>
-        </p:sp>
-      </p:grpSp>
-      <p:sp>
-        <p:nvSpPr>
-          <p:cNvPr id="103" name="Nube 102"/>
+            <a:off x="577794" y="2938603"/>
+            <a:ext cx="1225174" cy="646331"/>
+          </a:xfrm>
+          <a:prstGeom prst="rect">
+            <a:avLst/>
+          </a:prstGeom>
+          <a:noFill/>
+        </p:spPr>
+        <p:txBody>
+          <a:bodyPr wrap="square" rtlCol="0">
+            <a:spAutoFit/>
+          </a:bodyPr>
+          <a:lstStyle/>
+          <a:p>
+            <a:pPr algn="ctr"/>
+            <a:r>
+              <a:rPr lang="en-US" dirty="0" err="1" smtClean="0"/>
+              <a:t>capitales</a:t>
+            </a:r>
+            <a:r>
+              <a:rPr lang="en-US" dirty="0" smtClean="0"/>
+              <a:t/>
+            </a:r>
+            <a:br>
+              <a:rPr lang="en-US" dirty="0" smtClean="0"/>
+            </a:br>
+            <a:r>
+              <a:rPr lang="en-US" dirty="0" err="1" smtClean="0"/>
+              <a:t>externos</a:t>
+            </a:r>
+            <a:endParaRPr lang="es-ES_tradnl" dirty="0"/>
+          </a:p>
+        </p:txBody>
+      </p:sp>
+      <p:sp>
+        <p:nvSpPr>
+          <p:cNvPr id="102" name="Nube 101"/>
           <p:cNvSpPr/>
           <p:nvPr/>
         </p:nvSpPr>
         <p:spPr>
           <a:xfrm>
-            <a:off x="10275325" y="5440443"/>
-            <a:ext cx="1808804" cy="1211164"/>
+            <a:off x="1002546" y="2083064"/>
+            <a:ext cx="1535033" cy="551869"/>
           </a:xfrm>
           <a:prstGeom prst="cloud">
             <a:avLst/>
@@ -3784,6 +3642,118 @@
           <a:p>
             <a:pPr algn="ctr"/>
             <a:r>
+              <a:rPr lang="en-US" sz="1200" dirty="0" err="1" smtClean="0"/>
+              <a:t>Inversores</a:t>
+            </a:r>
+            <a:r>
+              <a:rPr lang="en-US" sz="1200" dirty="0" smtClean="0"/>
+              <a:t> y </a:t>
+            </a:r>
+            <a:r>
+              <a:rPr lang="en-US" sz="1200" dirty="0" err="1" smtClean="0"/>
+              <a:t>prestamistas</a:t>
+            </a:r>
+            <a:endParaRPr lang="es-ES_tradnl" sz="1200" dirty="0"/>
+          </a:p>
+        </p:txBody>
+      </p:sp>
+      <p:pic>
+        <p:nvPicPr>
+          <p:cNvPr id="5" name="Imagen 4" descr="Free photo: Water Pump, Industrial, Industry - Free Image ..."/>
+          <p:cNvPicPr>
+            <a:picLocks noChangeAspect="1"/>
+          </p:cNvPicPr>
+          <p:nvPr/>
+        </p:nvPicPr>
+        <p:blipFill>
+          <a:blip r:embed="rId3">
+            <a:extLst>
+              <a:ext uri="{28A0092B-C50C-407E-A947-70E740481C1C}">
+                <a14:useLocalDpi xmlns:a14="http://schemas.microsoft.com/office/drawing/2010/main" val="0"/>
+              </a:ext>
+            </a:extLst>
+          </a:blip>
+          <a:stretch>
+            <a:fillRect/>
+          </a:stretch>
+        </p:blipFill>
+        <p:spPr>
+          <a:xfrm>
+            <a:off x="8896785" y="5100088"/>
+            <a:ext cx="1482863" cy="988575"/>
+          </a:xfrm>
+          <a:prstGeom prst="rect">
+            <a:avLst/>
+          </a:prstGeom>
+        </p:spPr>
+      </p:pic>
+      <p:sp>
+        <p:nvSpPr>
+          <p:cNvPr id="104" name="CuadroTexto 103"/>
+          <p:cNvSpPr txBox="1"/>
+          <p:nvPr/>
+        </p:nvSpPr>
+        <p:spPr>
+          <a:xfrm>
+            <a:off x="10200435" y="5179049"/>
+            <a:ext cx="796244" cy="369332"/>
+          </a:xfrm>
+          <a:prstGeom prst="rect">
+            <a:avLst/>
+          </a:prstGeom>
+          <a:noFill/>
+        </p:spPr>
+        <p:txBody>
+          <a:bodyPr wrap="none" rtlCol="0">
+            <a:spAutoFit/>
+          </a:bodyPr>
+          <a:lstStyle/>
+          <a:p>
+            <a:r>
+              <a:rPr lang="en-US" dirty="0" err="1" smtClean="0"/>
+              <a:t>ventas</a:t>
+            </a:r>
+            <a:endParaRPr lang="es-ES_tradnl" dirty="0"/>
+          </a:p>
+        </p:txBody>
+      </p:sp>
+      <p:sp>
+        <p:nvSpPr>
+          <p:cNvPr id="103" name="Nube 102"/>
+          <p:cNvSpPr/>
+          <p:nvPr/>
+        </p:nvSpPr>
+        <p:spPr>
+          <a:xfrm>
+            <a:off x="10174238" y="5562869"/>
+            <a:ext cx="1808804" cy="1211164"/>
+          </a:xfrm>
+          <a:prstGeom prst="cloud">
+            <a:avLst/>
+          </a:prstGeom>
+        </p:spPr>
+        <p:style>
+          <a:lnRef idx="2">
+            <a:schemeClr val="accent1">
+              <a:shade val="50000"/>
+            </a:schemeClr>
+          </a:lnRef>
+          <a:fillRef idx="1">
+            <a:schemeClr val="accent1"/>
+          </a:fillRef>
+          <a:effectRef idx="0">
+            <a:schemeClr val="accent1"/>
+          </a:effectRef>
+          <a:fontRef idx="minor">
+            <a:schemeClr val="lt1"/>
+          </a:fontRef>
+        </p:style>
+        <p:txBody>
+          <a:bodyPr rtlCol="0" anchor="ctr"/>
+          <a:lstStyle/>
+          <a:p>
+            <a:pPr algn="ctr"/>
+            <a:r>
               <a:rPr lang="en-US" dirty="0" err="1" smtClean="0"/>
               <a:t>mercado</a:t>
             </a:r>
@@ -3794,15 +3764,13 @@
       <p:cxnSp>
         <p:nvCxnSpPr>
           <p:cNvPr id="113" name="Conector recto 112"/>
-          <p:cNvCxnSpPr>
-            <a:endCxn id="5" idx="3"/>
-          </p:cNvCxnSpPr>
+          <p:cNvCxnSpPr/>
           <p:nvPr/>
         </p:nvCxnSpPr>
         <p:spPr>
           <a:xfrm flipH="1">
-            <a:off x="10379648" y="3744658"/>
-            <a:ext cx="1211049" cy="1849718"/>
+            <a:off x="10566582" y="3744658"/>
+            <a:ext cx="1024116" cy="1377030"/>
           </a:xfrm>
           <a:prstGeom prst="line">
             <a:avLst/>
@@ -3946,39 +3914,6 @@
             <a:headEnd type="none" w="sm" len="sm"/>
             <a:tailEnd type="stealth" w="sm" len="sm"/>
           </a:ln>
-        </p:spPr>
-        <p:style>
-          <a:lnRef idx="1">
-            <a:schemeClr val="accent1"/>
-          </a:lnRef>
-          <a:fillRef idx="0">
-            <a:schemeClr val="accent1"/>
-          </a:fillRef>
-          <a:effectRef idx="0">
-            <a:schemeClr val="accent1"/>
-          </a:effectRef>
-          <a:fontRef idx="minor">
-            <a:schemeClr val="tx1"/>
-          </a:fontRef>
-        </p:style>
-      </p:cxnSp>
-      <p:cxnSp>
-        <p:nvCxnSpPr>
-          <p:cNvPr id="126" name="Conector recto 125"/>
-          <p:cNvCxnSpPr>
-            <a:endCxn id="5" idx="1"/>
-          </p:cNvCxnSpPr>
-          <p:nvPr/>
-        </p:nvCxnSpPr>
-        <p:spPr>
-          <a:xfrm>
-            <a:off x="8862625" y="4789096"/>
-            <a:ext cx="34160" cy="805280"/>
-          </a:xfrm>
-          <a:prstGeom prst="line">
-            <a:avLst/>
-          </a:prstGeom>
-          <a:ln w="127000"/>
         </p:spPr>
         <p:style>
           <a:lnRef idx="1">
@@ -4301,8 +4236,8 @@
         </p:nvCxnSpPr>
         <p:spPr>
           <a:xfrm flipV="1">
-            <a:off x="513800" y="2434483"/>
-            <a:ext cx="493507" cy="91278"/>
+            <a:off x="513800" y="2358999"/>
+            <a:ext cx="493507" cy="166762"/>
           </a:xfrm>
           <a:prstGeom prst="line">
             <a:avLst/>
@@ -4501,8 +4436,8 @@
         </p:nvSpPr>
         <p:spPr>
           <a:xfrm>
-            <a:off x="10062136" y="1371398"/>
-            <a:ext cx="1412952" cy="923330"/>
+            <a:off x="10204425" y="1436733"/>
+            <a:ext cx="1205098" cy="646331"/>
           </a:xfrm>
           <a:prstGeom prst="rect">
             <a:avLst/>
@@ -4510,7 +4445,7 @@
           <a:noFill/>
         </p:spPr>
         <p:txBody>
-          <a:bodyPr wrap="none" rtlCol="0">
+          <a:bodyPr wrap="square" rtlCol="0">
             <a:spAutoFit/>
           </a:bodyPr>
           <a:lstStyle/>
@@ -4524,7 +4459,7 @@
                   </a:schemeClr>
                 </a:solidFill>
               </a:rPr>
-              <a:t>t</a:t>
+              <a:t>c</a:t>
             </a:r>
             <a:r>
               <a:rPr lang="en-US" dirty="0" err="1" smtClean="0">
@@ -4534,67 +4469,27 @@
                   </a:schemeClr>
                 </a:solidFill>
               </a:rPr>
-              <a:t>ransferencia</a:t>
-            </a:r>
-            <a:endParaRPr lang="en-US" dirty="0" smtClean="0">
-              <a:solidFill>
-                <a:schemeClr val="accent6">
-                  <a:lumMod val="75000"/>
-                </a:schemeClr>
-              </a:solidFill>
-            </a:endParaRPr>
-          </a:p>
-          <a:p>
-            <a:pPr algn="ctr"/>
-            <a:r>
-              <a:rPr lang="en-US" dirty="0" err="1" smtClean="0">
+              <a:t>aja</a:t>
+            </a:r>
+            <a:r>
+              <a:rPr lang="en-US" dirty="0" smtClean="0">
                 <a:solidFill>
                   <a:schemeClr val="accent6">
                     <a:lumMod val="75000"/>
                   </a:schemeClr>
                 </a:solidFill>
               </a:rPr>
-              <a:t>efectiva</a:t>
-            </a:r>
-            <a:endParaRPr lang="en-US" dirty="0" smtClean="0">
-              <a:solidFill>
-                <a:schemeClr val="accent6">
-                  <a:lumMod val="75000"/>
-                </a:schemeClr>
-              </a:solidFill>
-            </a:endParaRPr>
-          </a:p>
-          <a:p>
-            <a:pPr algn="ctr"/>
-            <a:r>
-              <a:rPr lang="en-US" dirty="0" smtClean="0">
+              <a:t> </a:t>
+            </a:r>
+            <a:r>
+              <a:rPr lang="en-US" dirty="0" err="1" smtClean="0">
                 <a:solidFill>
                   <a:schemeClr val="accent6">
                     <a:lumMod val="75000"/>
                   </a:schemeClr>
                 </a:solidFill>
               </a:rPr>
-              <a:t>(</a:t>
-            </a:r>
-            <a:r>
-              <a:rPr lang="en-US" sz="1400" dirty="0" smtClean="0">
-                <a:solidFill>
-                  <a:schemeClr val="accent6">
-                    <a:lumMod val="75000"/>
-                  </a:schemeClr>
-                </a:solidFill>
-              </a:rPr>
-              <a:t>throughput</a:t>
-            </a:r>
-            <a:r>
-              <a:rPr lang="en-US" dirty="0" smtClean="0">
-                <a:solidFill>
-                  <a:schemeClr val="accent6">
-                    <a:lumMod val="75000"/>
-                  </a:schemeClr>
-                </a:solidFill>
-              </a:rPr>
-              <a:t>)</a:t>
+              <a:t>entrante</a:t>
             </a:r>
             <a:endParaRPr lang="es-ES_tradnl" dirty="0">
               <a:solidFill>
@@ -4702,7 +4597,7 @@
         </p:nvSpPr>
         <p:spPr>
           <a:xfrm>
-            <a:off x="8922982" y="4797464"/>
+            <a:off x="8973488" y="4752356"/>
             <a:ext cx="490840" cy="369332"/>
           </a:xfrm>
           <a:prstGeom prst="rect">
@@ -4846,8 +4741,8 @@
           </p:sp>
         </mc:Fallback>
       </mc:AlternateContent>
-      <mc:AlternateContent xmlns:mc="http://schemas.openxmlformats.org/markup-compatibility/2006" xmlns:a14="http://schemas.microsoft.com/office/drawing/2010/main">
-        <mc:Choice Requires="a14">
+      <mc:AlternateContent xmlns:mc="http://schemas.openxmlformats.org/markup-compatibility/2006">
+        <mc:Choice xmlns:a14="http://schemas.microsoft.com/office/drawing/2010/main" Requires="a14">
           <p:sp>
             <p:nvSpPr>
               <p:cNvPr id="238" name="CuadroTexto 237"/>
@@ -4856,8 +4751,8 @@
             </p:nvSpPr>
             <p:spPr>
               <a:xfrm>
-                <a:off x="1157408" y="5469712"/>
-                <a:ext cx="3066659" cy="485454"/>
+                <a:off x="1157409" y="5469711"/>
+                <a:ext cx="3065013" cy="485454"/>
               </a:xfrm>
               <a:prstGeom prst="rect">
                 <a:avLst/>
@@ -4922,7 +4817,7 @@
             </p:txBody>
           </p:sp>
         </mc:Choice>
-        <mc:Fallback xmlns="">
+        <mc:Fallback>
           <p:sp>
             <p:nvSpPr>
               <p:cNvPr id="238" name="CuadroTexto 237"/>
@@ -4933,8 +4828,8 @@
             </p:nvSpPr>
             <p:spPr>
               <a:xfrm>
-                <a:off x="1157408" y="5469712"/>
-                <a:ext cx="3066659" cy="485454"/>
+                <a:off x="1157409" y="5469711"/>
+                <a:ext cx="3065013" cy="485454"/>
               </a:xfrm>
               <a:prstGeom prst="rect">
                 <a:avLst/>
@@ -4951,7 +4846,7 @@
               <a:lstStyle/>
               <a:p>
                 <a:r>
-                  <a:rPr lang="es-ES_tradnl">
+                  <a:rPr lang="es-ES">
                     <a:noFill/>
                   </a:rPr>
                   <a:t> </a:t>
@@ -4969,7 +4864,7 @@
         </p:nvSpPr>
         <p:spPr>
           <a:xfrm>
-            <a:off x="10383838" y="4512740"/>
+            <a:off x="10088392" y="4716268"/>
             <a:ext cx="478190" cy="369332"/>
           </a:xfrm>
           <a:prstGeom prst="rect">
@@ -5285,7 +5180,7 @@
         </p:nvSpPr>
         <p:spPr>
           <a:xfrm>
-            <a:off x="7948954" y="3262051"/>
+            <a:off x="7808119" y="3296635"/>
             <a:ext cx="1222001" cy="369332"/>
           </a:xfrm>
           <a:prstGeom prst="rect">
@@ -5317,6 +5212,78 @@
                 </a:schemeClr>
               </a:solidFill>
             </a:endParaRPr>
+          </a:p>
+        </p:txBody>
+      </p:sp>
+      <p:cxnSp>
+        <p:nvCxnSpPr>
+          <p:cNvPr id="63" name="Conector recto 62"/>
+          <p:cNvCxnSpPr/>
+          <p:nvPr/>
+        </p:nvCxnSpPr>
+        <p:spPr>
+          <a:xfrm>
+            <a:off x="8864696" y="4848284"/>
+            <a:ext cx="58286" cy="592159"/>
+          </a:xfrm>
+          <a:prstGeom prst="line">
+            <a:avLst/>
+          </a:prstGeom>
+          <a:ln w="165100">
+            <a:headEnd type="none" w="sm" len="sm"/>
+            <a:tailEnd type="stealth" w="sm" len="sm"/>
+          </a:ln>
+        </p:spPr>
+        <p:style>
+          <a:lnRef idx="1">
+            <a:schemeClr val="accent1"/>
+          </a:lnRef>
+          <a:fillRef idx="0">
+            <a:schemeClr val="accent1"/>
+          </a:fillRef>
+          <a:effectRef idx="0">
+            <a:schemeClr val="accent1"/>
+          </a:effectRef>
+          <a:fontRef idx="minor">
+            <a:schemeClr val="tx1"/>
+          </a:fontRef>
+        </p:style>
+      </p:cxnSp>
+      <p:sp>
+        <p:nvSpPr>
+          <p:cNvPr id="11" name="CuadroTexto 10"/>
+          <p:cNvSpPr txBox="1"/>
+          <p:nvPr/>
+        </p:nvSpPr>
+        <p:spPr>
+          <a:xfrm>
+            <a:off x="3807290" y="6352715"/>
+            <a:ext cx="4503630" cy="400110"/>
+          </a:xfrm>
+          <a:prstGeom prst="rect">
+            <a:avLst/>
+          </a:prstGeom>
+          <a:noFill/>
+        </p:spPr>
+        <p:txBody>
+          <a:bodyPr wrap="square" rtlCol="0">
+            <a:spAutoFit/>
+          </a:bodyPr>
+          <a:lstStyle/>
+          <a:p>
+            <a:r>
+              <a:rPr lang="es-ES" sz="1000" dirty="0" smtClean="0"/>
+              <a:t>Nota: las fórmulas de `resultado neto` y `retorno de inversión` están simplificadas, no se contemplan efectos detallados de </a:t>
+            </a:r>
+            <a:r>
+              <a:rPr lang="es-ES" sz="1000" dirty="0" err="1" smtClean="0"/>
+              <a:t>periodificación</a:t>
+            </a:r>
+            <a:r>
+              <a:rPr lang="es-ES" sz="1000" dirty="0" smtClean="0"/>
+              <a:t> en su tratamiento contable.</a:t>
+            </a:r>
+            <a:endParaRPr lang="es-ES" sz="1000" dirty="0"/>
           </a:p>
         </p:txBody>
       </p:sp>
@@ -7183,17 +7150,8 @@
             </a:r>
             <a:r>
               <a:rPr lang="es-ES" sz="3200" dirty="0"/>
-              <a:t>entre </a:t>
-            </a:r>
-            <a:r>
-              <a:rPr lang="es-ES" sz="3200" dirty="0"/>
-              <a:t>FINANZAS</a:t>
-            </a:r>
-            <a:r>
-              <a:rPr lang="es-ES" sz="3200" dirty="0"/>
-              <a:t> y CONTABILIDAD</a:t>
-            </a:r>
-            <a:endParaRPr lang="es-ES" sz="3200" dirty="0"/>
+              <a:t>entre FINANZAS y CONTABILIDAD</a:t>
+            </a:r>
           </a:p>
         </p:txBody>
       </p:sp>

</xml_diff>